<commit_message>
Module 10: remove the own-client option (eight client packs only)
Co-Authored-By: Claude Sonnet 5.5 <noreply@anthropic.com>
Claude-Session: https://claude.ai/code/session_01UqHdqh2796rZQzuF7uxH3N
</commit_message>
<xml_diff>
--- a/downloads/module-10-slides.pptx
+++ b/downloads/module-10-slides.pptx
@@ -4597,45 +4597,6 @@
           </a:p>
         </p:txBody>
       </p:sp>
-      <p:sp>
-        <p:nvSpPr>
-          <p:cNvPr id="24" name="Text 22"/>
-          <p:cNvSpPr txBox="1"/>
-          <p:nvPr/>
-        </p:nvSpPr>
-        <p:spPr>
-          <a:xfrm>
-            <a:off x="548640" y="5440680"/>
-            <a:ext cx="11064240" cy="548640"/>
-          </a:xfrm>
-          <a:prstGeom prst="rect">
-            <a:avLst/>
-          </a:prstGeom>
-          <a:noFill/>
-          <a:ln/>
-        </p:spPr>
-        <p:txBody>
-          <a:bodyPr wrap="square" lIns="0" tIns="0" rIns="0" bIns="0" rtlCol="0" anchor="ctr"/>
-          <a:lstStyle/>
-          <a:p>
-            <a:pPr indent="0" marL="0">
-              <a:buNone/>
-            </a:pPr>
-            <a:r>
-              <a:rPr lang="en-US" sz="2000" i="1" dirty="0">
-                <a:solidFill>
-                  <a:srgbClr val="C8102E"/>
-                </a:solidFill>
-                <a:latin typeface="Calibri" pitchFamily="34" charset="0"/>
-                <a:ea typeface="Calibri" pitchFamily="34" charset="-122"/>
-                <a:cs typeface="Calibri" pitchFamily="34" charset="-120"/>
-              </a:rPr>
-              <a:t>Or propose your own client, with your instructor’s approval first.</a:t>
-            </a:r>
-            <a:endParaRPr lang="en-US" sz="2000" dirty="0"/>
-          </a:p>
-        </p:txBody>
-      </p:sp>
     </p:spTree>
   </p:cSld>
   <p:clrMapOvr>

</xml_diff>